<commit_message>
main restucture: seperated GameOver handling
</commit_message>
<xml_diff>
--- a/docs/unfiltered-ideas/block_diagram.ppt.pptx
+++ b/docs/unfiltered-ideas/block_diagram.ppt.pptx
@@ -5,8 +5,8 @@
     <p:sldMasterId id="2147483648" r:id="rId1"/>
   </p:sldMasterIdLst>
   <p:sldIdLst>
-    <p:sldId id="256" r:id="rId2"/>
-    <p:sldId id="257" r:id="rId3"/>
+    <p:sldId id="257" r:id="rId2"/>
+    <p:sldId id="258" r:id="rId3"/>
   </p:sldIdLst>
   <p:sldSz cx="12192000" cy="6858000"/>
   <p:notesSz cx="6858000" cy="9144000"/>
@@ -3308,86 +3308,14 @@
 <file path=ppt/slides/slide1.xml><?xml version="1.0" encoding="utf-8"?>
 <p:sld xmlns:a="http://schemas.openxmlformats.org/drawingml/2006/main" xmlns:r="http://schemas.openxmlformats.org/officeDocument/2006/relationships" xmlns:p="http://schemas.openxmlformats.org/presentationml/2006/main">
   <p:cSld>
-    <p:spTree>
-      <p:nvGrpSpPr>
-        <p:cNvPr id="1" name=""/>
-        <p:cNvGrpSpPr/>
-        <p:nvPr/>
-      </p:nvGrpSpPr>
-      <p:grpSpPr>
-        <a:xfrm>
-          <a:off x="0" y="0"/>
-          <a:ext cx="0" cy="0"/>
-          <a:chOff x="0" y="0"/>
-          <a:chExt cx="0" cy="0"/>
-        </a:xfrm>
-      </p:grpSpPr>
-      <p:sp>
-        <p:nvSpPr>
-          <p:cNvPr id="2" name="Title 1">
-            <a:extLst>
-              <a:ext uri="{FF2B5EF4-FFF2-40B4-BE49-F238E27FC236}">
-                <a16:creationId xmlns:a16="http://schemas.microsoft.com/office/drawing/2014/main" id="{182D15D3-1F36-3819-1C56-6116FADA479B}"/>
-              </a:ext>
-            </a:extLst>
-          </p:cNvPr>
-          <p:cNvSpPr>
-            <a:spLocks noGrp="1"/>
-          </p:cNvSpPr>
-          <p:nvPr>
-            <p:ph type="ctrTitle"/>
-          </p:nvPr>
-        </p:nvSpPr>
-        <p:spPr/>
-        <p:txBody>
-          <a:bodyPr/>
-          <a:lstStyle/>
-          <a:p>
-            <a:endParaRPr lang="en-US"/>
-          </a:p>
-        </p:txBody>
-      </p:sp>
-      <p:sp>
-        <p:nvSpPr>
-          <p:cNvPr id="3" name="Subtitle 2">
-            <a:extLst>
-              <a:ext uri="{FF2B5EF4-FFF2-40B4-BE49-F238E27FC236}">
-                <a16:creationId xmlns:a16="http://schemas.microsoft.com/office/drawing/2014/main" id="{5E513C0F-04D3-5BB0-6516-342F294B4C97}"/>
-              </a:ext>
-            </a:extLst>
-          </p:cNvPr>
-          <p:cNvSpPr>
-            <a:spLocks noGrp="1"/>
-          </p:cNvSpPr>
-          <p:nvPr>
-            <p:ph type="subTitle" idx="1"/>
-          </p:nvPr>
-        </p:nvSpPr>
-        <p:spPr/>
-        <p:txBody>
-          <a:bodyPr/>
-          <a:lstStyle/>
-          <a:p>
-            <a:endParaRPr lang="en-US"/>
-          </a:p>
-        </p:txBody>
-      </p:sp>
-    </p:spTree>
-    <p:extLst>
-      <p:ext uri="{BB962C8B-B14F-4D97-AF65-F5344CB8AC3E}">
-        <p14:creationId xmlns:p14="http://schemas.microsoft.com/office/powerpoint/2010/main" val="4184162605"/>
-      </p:ext>
-    </p:extLst>
-  </p:cSld>
-  <p:clrMapOvr>
-    <a:masterClrMapping/>
-  </p:clrMapOvr>
-</p:sld>
-</file>
-
-<file path=ppt/slides/slide2.xml><?xml version="1.0" encoding="utf-8"?>
-<p:sld xmlns:a="http://schemas.openxmlformats.org/drawingml/2006/main" xmlns:r="http://schemas.openxmlformats.org/officeDocument/2006/relationships" xmlns:p="http://schemas.openxmlformats.org/presentationml/2006/main">
-  <p:cSld>
+    <p:bg>
+      <p:bgPr>
+        <a:solidFill>
+          <a:schemeClr val="bg1"/>
+        </a:solidFill>
+        <a:effectLst/>
+      </p:bgPr>
+    </p:bg>
     <p:spTree>
       <p:nvGrpSpPr>
         <p:cNvPr id="1" name=""/>
@@ -3985,6 +3913,74 @@
     <p:extLst>
       <p:ext uri="{BB962C8B-B14F-4D97-AF65-F5344CB8AC3E}">
         <p14:creationId xmlns:p14="http://schemas.microsoft.com/office/powerpoint/2010/main" val="450435223"/>
+      </p:ext>
+    </p:extLst>
+  </p:cSld>
+  <p:clrMapOvr>
+    <a:masterClrMapping/>
+  </p:clrMapOvr>
+</p:sld>
+</file>
+
+<file path=ppt/slides/slide2.xml><?xml version="1.0" encoding="utf-8"?>
+<p:sld xmlns:a="http://schemas.openxmlformats.org/drawingml/2006/main" xmlns:r="http://schemas.openxmlformats.org/officeDocument/2006/relationships" xmlns:p="http://schemas.openxmlformats.org/presentationml/2006/main">
+  <p:cSld>
+    <p:bg>
+      <p:bgPr>
+        <a:solidFill>
+          <a:schemeClr val="tx1"/>
+        </a:solidFill>
+        <a:effectLst/>
+      </p:bgPr>
+    </p:bg>
+    <p:spTree>
+      <p:nvGrpSpPr>
+        <p:cNvPr id="1" name=""/>
+        <p:cNvGrpSpPr/>
+        <p:nvPr/>
+      </p:nvGrpSpPr>
+      <p:grpSpPr>
+        <a:xfrm>
+          <a:off x="0" y="0"/>
+          <a:ext cx="0" cy="0"/>
+          <a:chOff x="0" y="0"/>
+          <a:chExt cx="0" cy="0"/>
+        </a:xfrm>
+      </p:grpSpPr>
+      <p:pic>
+        <p:nvPicPr>
+          <p:cNvPr id="4" name="Picture 3">
+            <a:extLst>
+              <a:ext uri="{FF2B5EF4-FFF2-40B4-BE49-F238E27FC236}">
+                <a16:creationId xmlns:a16="http://schemas.microsoft.com/office/drawing/2014/main" id="{FD3CA8F5-EE5E-86A1-A7D7-6600F1CB43C4}"/>
+              </a:ext>
+            </a:extLst>
+          </p:cNvPr>
+          <p:cNvPicPr>
+            <a:picLocks noChangeAspect="1"/>
+          </p:cNvPicPr>
+          <p:nvPr/>
+        </p:nvPicPr>
+        <p:blipFill>
+          <a:blip r:embed="rId2"/>
+          <a:stretch>
+            <a:fillRect/>
+          </a:stretch>
+        </p:blipFill>
+        <p:spPr>
+          <a:xfrm>
+            <a:off x="3705726" y="1124764"/>
+            <a:ext cx="3549587" cy="2715481"/>
+          </a:xfrm>
+          <a:prstGeom prst="rect">
+            <a:avLst/>
+          </a:prstGeom>
+        </p:spPr>
+      </p:pic>
+    </p:spTree>
+    <p:extLst>
+      <p:ext uri="{BB962C8B-B14F-4D97-AF65-F5344CB8AC3E}">
+        <p14:creationId xmlns:p14="http://schemas.microsoft.com/office/powerpoint/2010/main" val="2649018293"/>
       </p:ext>
     </p:extLst>
   </p:cSld>

</xml_diff>